<commit_message>
Embed tiering as design requirement + intake gate in main pipeline
- PRD(html/docx) 注入「课程分层 3×2 矩阵（设计要求·前置判定）」章节：Pipeline 新增第0阶段 Course Intake & Tiering
- Sample_Input_Checklist(docx/pptx) 新增第11项「分层与前置判定」自评 + Pipeline 前置示意
- validation_rules.json 增 VR-INTAKE01(BLOCKER, 无分层判定不得进 Pipeline) -> 44条(24B/17W/3I)
- Capability_Assets 重渲染（含 VR-INTAKE01）；Skill 同步已安装副本
- README 更新（前置判定说明 + 44 条）
</commit_message>
<xml_diff>
--- a/docs/Sample_Input_Checklist.pptx
+++ b/docs/Sample_Input_Checklist.pptx
@@ -28,6 +28,8 @@
     <p:sldId id="276" r:id="rId27"/>
     <p:sldId id="277" r:id="rId28"/>
     <p:sldId id="278" r:id="rId29"/>
+    <p:sldId id="279" r:id="rId30"/>
+    <p:sldId id="280" r:id="rId31"/>
   </p:sldIdLst>
   <p:sldSz cx="12191695" cy="6858000" type="screen4x3"/>
   <p:notesSz cx="6858000" cy="9144000"/>
@@ -3427,15 +3429,15 @@
         <p:spPr>
           <a:xfrm>
             <a:off x="548640" y="457200"/>
-            <a:ext cx="11064240" cy="731520"/>
-          </a:xfrm>
-          <a:prstGeom prst="rect">
-            <a:avLst/>
-          </a:prstGeom>
-          <a:noFill/>
-        </p:spPr>
-        <p:txBody>
-          <a:bodyPr wrap="none">
+            <a:ext cx="11064240" cy="914400"/>
+          </a:xfrm>
+          <a:prstGeom prst="rect">
+            <a:avLst/>
+          </a:prstGeom>
+          <a:noFill/>
+        </p:spPr>
+        <p:txBody>
+          <a:bodyPr wrap="square">
             <a:spAutoFit/>
           </a:bodyPr>
           <a:lstStyle/>
@@ -3446,7 +3448,68 @@
                   <a:srgbClr val="0E6B50"/>
                 </a:solidFill>
               </a:rPr>
-              <a:t>情境领导课程 · 示范填写</a:t>
+              <a:t>11. 分层与前置判定（Tier × Track）   〔🟠 建议〕</a:t>
+            </a:r>
+          </a:p>
+        </p:txBody>
+      </p:sp>
+      <p:sp>
+        <p:nvSpPr>
+          <p:cNvPr id="3" name="TextBox 2"/>
+          <p:cNvSpPr txBox="1"/>
+          <p:nvPr/>
+        </p:nvSpPr>
+        <p:spPr>
+          <a:xfrm>
+            <a:off x="548640" y="1554480"/>
+            <a:ext cx="11064240" cy="1828800"/>
+          </a:xfrm>
+          <a:prstGeom prst="rect">
+            <a:avLst/>
+          </a:prstGeom>
+          <a:noFill/>
+        </p:spPr>
+        <p:txBody>
+          <a:bodyPr wrap="square">
+            <a:spAutoFit/>
+          </a:bodyPr>
+          <a:lstStyle/>
+          <a:p>
+            <a:r>
+              <a:rPr sz="1500"/>
+              <a:t>填写说明：
+这门课打算做成哪一层？——L1 轻量切片 3h / L2 标准单元 7h / L3 深度系列 14h（AVG 探索固定占 50%）。哪一类？——C1 通用改编（已有课程转译）/ C2 定制业务赋能（从业务目标萃取构建）。给出非 AVG 50% 内 导入/复盘/应用/IDP 的大致分配。Intake Agent 会复核此判定。</a:t>
+            </a:r>
+          </a:p>
+        </p:txBody>
+      </p:sp>
+      <p:sp>
+        <p:nvSpPr>
+          <p:cNvPr id="4" name="TextBox 3"/>
+          <p:cNvSpPr txBox="1"/>
+          <p:nvPr/>
+        </p:nvSpPr>
+        <p:spPr>
+          <a:xfrm>
+            <a:off x="548640" y="3566160"/>
+            <a:ext cx="11064240" cy="2560320"/>
+          </a:xfrm>
+          <a:prstGeom prst="rect">
+            <a:avLst/>
+          </a:prstGeom>
+          <a:noFill/>
+        </p:spPr>
+        <p:txBody>
+          <a:bodyPr wrap="square">
+            <a:spAutoFit/>
+          </a:bodyPr>
+          <a:lstStyle/>
+          <a:p>
+            <a:r>
+              <a:rPr sz="1500"/>
+              <a:t>你的填写：
+_________________________________________________
+</a:t>
             </a:r>
           </a:p>
         </p:txBody>
@@ -3478,55 +3541,26 @@
         <p:spPr>
           <a:xfrm>
             <a:off x="548640" y="457200"/>
-            <a:ext cx="11064240" cy="822960"/>
-          </a:xfrm>
-          <a:prstGeom prst="rect">
-            <a:avLst/>
-          </a:prstGeom>
-          <a:noFill/>
-        </p:spPr>
-        <p:txBody>
-          <a:bodyPr wrap="square">
-            <a:spAutoFit/>
-          </a:bodyPr>
-          <a:lstStyle/>
-          <a:p>
-            <a:r>
-              <a:rPr sz="2000" b="1">
+            <a:ext cx="11064240" cy="731520"/>
+          </a:xfrm>
+          <a:prstGeom prst="rect">
+            <a:avLst/>
+          </a:prstGeom>
+          <a:noFill/>
+        </p:spPr>
+        <p:txBody>
+          <a:bodyPr wrap="none">
+            <a:spAutoFit/>
+          </a:bodyPr>
+          <a:lstStyle/>
+          <a:p>
+            <a:r>
+              <a:rPr sz="2400" b="1">
                 <a:solidFill>
                   <a:srgbClr val="0E6B50"/>
                 </a:solidFill>
               </a:rPr>
-              <a:t>1 · 课程基本信息</a:t>
-            </a:r>
-          </a:p>
-        </p:txBody>
-      </p:sp>
-      <p:sp>
-        <p:nvSpPr>
-          <p:cNvPr id="3" name="TextBox 2"/>
-          <p:cNvSpPr txBox="1"/>
-          <p:nvPr/>
-        </p:nvSpPr>
-        <p:spPr>
-          <a:xfrm>
-            <a:off x="548640" y="1463040"/>
-            <a:ext cx="11064240" cy="4572000"/>
-          </a:xfrm>
-          <a:prstGeom prst="rect">
-            <a:avLst/>
-          </a:prstGeom>
-          <a:noFill/>
-        </p:spPr>
-        <p:txBody>
-          <a:bodyPr wrap="square">
-            <a:spAutoFit/>
-          </a:bodyPr>
-          <a:lstStyle/>
-          <a:p>
-            <a:r>
-              <a:rPr sz="1500"/>
-              <a:t>《情境领导®（Situational Leadership®）》企业内训；1 天（6.5h）；模块：①领导风格认知 ②成熟度诊断 ③风格匹配 ④授权与跟进；目标学员：新任 / 中层经理。先切模块③“风格匹配”做切片（最有戏、最易成 Decision 节点）。</a:t>
+              <a:t>情境领导课程 · 示范填写</a:t>
             </a:r>
           </a:p>
         </p:txBody>
@@ -3577,7 +3611,7 @@
                   <a:srgbClr val="0E6B50"/>
                 </a:solidFill>
               </a:rPr>
-              <a:t>2 · 学习目标与能力模型</a:t>
+              <a:t>1 · 课程基本信息</a:t>
             </a:r>
           </a:p>
         </p:txBody>
@@ -3606,7 +3640,7 @@
           <a:p>
             <a:r>
               <a:rPr sz="1500"/>
-              <a:t>学完学员能——(a) 判定下属在“任务 / 关系”维度的成熟度（R1–R4）；(b) 在 S1–S4 四种领导风格中匹配正确风格；(c) 在下属成熟度变化时动态调整。行为动词：能诊断、能匹配、能调整。</a:t>
+              <a:t>《情境领导®（Situational Leadership®）》企业内训；1 天（6.5h）；模块：①领导风格认知 ②成熟度诊断 ③风格匹配 ④授权与跟进；目标学员：新任 / 中层经理。先切模块③“风格匹配”做切片（最有戏、最易成 Decision 节点）。</a:t>
             </a:r>
           </a:p>
         </p:txBody>
@@ -3657,7 +3691,7 @@
                   <a:srgbClr val="0E6B50"/>
                 </a:solidFill>
               </a:rPr>
-              <a:t>3 · 学员对象与真实场景背景</a:t>
+              <a:t>2 · 学习目标与能力模型</a:t>
             </a:r>
           </a:p>
         </p:txBody>
@@ -3686,7 +3720,7 @@
           <a:p>
             <a:r>
               <a:rPr sz="1500"/>
-              <a:t>新任经理（带 3–8 人团队，0–2 年管理经验）。真实情境：下属突然业绩下滑 / 资深下属不服管 / 新人频繁求助却不敢放手。</a:t>
+              <a:t>学完学员能——(a) 判定下属在“任务 / 关系”维度的成熟度（R1–R4）；(b) 在 S1–S4 四种领导风格中匹配正确风格；(c) 在下属成熟度变化时动态调整。行为动词：能诊断、能匹配、能调整。</a:t>
             </a:r>
           </a:p>
         </p:txBody>
@@ -3737,7 +3771,7 @@
                   <a:srgbClr val="0E6B50"/>
                 </a:solidFill>
               </a:rPr>
-              <a:t>4 · 现有考核与课堂活动</a:t>
+              <a:t>3 · 学员对象与真实场景背景</a:t>
             </a:r>
           </a:p>
         </p:txBody>
@@ -3766,7 +3800,7 @@
           <a:p>
             <a:r>
               <a:rPr sz="1500"/>
-              <a:t>现用“风格-成熟度匹配测验”+ 角色扮演（给一个下属画像，让学员选风格并说明理由）；小组讨论“最难的带人场景”。→ 角色扮演可直接转 Decision 节点，小组讨论转 Reflection。</a:t>
+              <a:t>新任经理（带 3–8 人团队，0–2 年管理经验）。真实情境：下属突然业绩下滑 / 资深下属不服管 / 新人频繁求助却不敢放手。</a:t>
             </a:r>
           </a:p>
         </p:txBody>
@@ -3817,7 +3851,7 @@
                   <a:srgbClr val="0E6B50"/>
                 </a:solidFill>
               </a:rPr>
-              <a:t>5 · 标志性案例 / 真实两难</a:t>
+              <a:t>4 · 现有考核与课堂活动</a:t>
             </a:r>
           </a:p>
         </p:txBody>
@@ -3846,7 +3880,7 @@
           <a:p>
             <a:r>
               <a:rPr sz="1500"/>
-              <a:t>“老周的两难”——技术骨干老周被提拔成主管，仍习惯自己上手，团队怨声载道；上级要求他“放权”但项目紧急。这是真实两难（S1 指令式 vs S3 参与式拉扯），绝佳剧本种子。</a:t>
+              <a:t>现用“风格-成熟度匹配测验”+ 角色扮演（给一个下属画像，让学员选风格并说明理由）；小组讨论“最难的带人场景”。→ 角色扮演可直接转 Decision 节点，小组讨论转 Reflection。</a:t>
             </a:r>
           </a:p>
         </p:txBody>
@@ -3897,7 +3931,7 @@
                   <a:srgbClr val="0E6B50"/>
                 </a:solidFill>
               </a:rPr>
-              <a:t>6 · “好课”参照</a:t>
+              <a:t>5 · 标志性案例 / 真实两难</a:t>
             </a:r>
           </a:p>
         </p:txBody>
@@ -3926,7 +3960,7 @@
           <a:p>
             <a:r>
               <a:rPr sz="1500"/>
-              <a:t>顿悟时刻是“原来不是下属不行，是我用错了风格”。引导话术示例：“如果你是这个主管，此刻你最怕什么？”</a:t>
+              <a:t>“老周的两难”——技术骨干老周被提拔成主管，仍习惯自己上手，团队怨声载道；上级要求他“放权”但项目紧急。这是真实两难（S1 指令式 vs S3 参与式拉扯），绝佳剧本种子。</a:t>
             </a:r>
           </a:p>
         </p:txBody>
@@ -3977,7 +4011,7 @@
                   <a:srgbClr val="0E6B50"/>
                 </a:solidFill>
               </a:rPr>
-              <a:t>7 · 品牌 / 视觉 / 脱敏</a:t>
+              <a:t>6 · “好课”参照</a:t>
             </a:r>
           </a:p>
         </p:txBody>
@@ -4006,7 +4040,7 @@
           <a:p>
             <a:r>
               <a:rPr sz="1500"/>
-              <a:t>可用客户内部案例（脱敏），主色沿用客户品牌蓝；不外泄真实姓名；物料印刷需 CMYK 合规。</a:t>
+              <a:t>顿悟时刻是“原来不是下属不行，是我用错了风格”。引导话术示例：“如果你是这个主管，此刻你最怕什么？”</a:t>
             </a:r>
           </a:p>
         </p:txBody>
@@ -4169,7 +4203,7 @@
                   <a:srgbClr val="0E6B50"/>
                 </a:solidFill>
               </a:rPr>
-              <a:t>8 · 期望产出形态</a:t>
+              <a:t>7 · 品牌 / 视觉 / 脱敏</a:t>
             </a:r>
           </a:p>
         </p:txBody>
@@ -4198,7 +4232,7 @@
           <a:p>
             <a:r>
               <a:rPr sz="1500"/>
-              <a:t>剧本杀式（主管扮演 + 下属 NPC + 抉择）+ 轻量分支复盘。</a:t>
+              <a:t>可用客户内部案例（脱敏），主色沿用客户品牌蓝；不外泄真实姓名；物料印刷需 CMYK 合规。</a:t>
             </a:r>
           </a:p>
         </p:txBody>
@@ -4249,7 +4283,7 @@
                   <a:srgbClr val="0E6B50"/>
                 </a:solidFill>
               </a:rPr>
-              <a:t>9 · 试点成功标准</a:t>
+              <a:t>8 · 期望产出形态</a:t>
             </a:r>
           </a:p>
         </p:txBody>
@@ -4278,7 +4312,7 @@
           <a:p>
             <a:r>
               <a:rPr sz="1500"/>
-              <a:t>能打印成离线包、由客户内部讲师带 1 期 20 人工作坊、学员产出“我的风格调整行动计划”。</a:t>
+              <a:t>剧本杀式（主管扮演 + 下属 NPC + 抉择）+ 轻量分支复盘。</a:t>
             </a:r>
           </a:p>
         </p:txBody>
@@ -4329,7 +4363,7 @@
                   <a:srgbClr val="0E6B50"/>
                 </a:solidFill>
               </a:rPr>
-              <a:t>10 · 文件清单</a:t>
+              <a:t>9 · 试点成功标准</a:t>
             </a:r>
           </a:p>
         </p:txBody>
@@ -4358,7 +4392,7 @@
           <a:p>
             <a:r>
               <a:rPr sz="1500"/>
-              <a:t>授课 PPT：SL_PPT.pptx（含四模块、匹配测验）；教材：SL_Manual.pdf（情境领导原著节选 + 案例）。</a:t>
+              <a:t>能打印成离线包、由客户内部讲师带 1 期 20 人工作坊、学员产出“我的风格调整行动计划”。</a:t>
             </a:r>
           </a:p>
         </p:txBody>
@@ -4390,6 +4424,166 @@
         <p:spPr>
           <a:xfrm>
             <a:off x="548640" y="457200"/>
+            <a:ext cx="11064240" cy="822960"/>
+          </a:xfrm>
+          <a:prstGeom prst="rect">
+            <a:avLst/>
+          </a:prstGeom>
+          <a:noFill/>
+        </p:spPr>
+        <p:txBody>
+          <a:bodyPr wrap="square">
+            <a:spAutoFit/>
+          </a:bodyPr>
+          <a:lstStyle/>
+          <a:p>
+            <a:r>
+              <a:rPr sz="2000" b="1">
+                <a:solidFill>
+                  <a:srgbClr val="0E6B50"/>
+                </a:solidFill>
+              </a:rPr>
+              <a:t>10 · 文件清单</a:t>
+            </a:r>
+          </a:p>
+        </p:txBody>
+      </p:sp>
+      <p:sp>
+        <p:nvSpPr>
+          <p:cNvPr id="3" name="TextBox 2"/>
+          <p:cNvSpPr txBox="1"/>
+          <p:nvPr/>
+        </p:nvSpPr>
+        <p:spPr>
+          <a:xfrm>
+            <a:off x="548640" y="1463040"/>
+            <a:ext cx="11064240" cy="4572000"/>
+          </a:xfrm>
+          <a:prstGeom prst="rect">
+            <a:avLst/>
+          </a:prstGeom>
+          <a:noFill/>
+        </p:spPr>
+        <p:txBody>
+          <a:bodyPr wrap="square">
+            <a:spAutoFit/>
+          </a:bodyPr>
+          <a:lstStyle/>
+          <a:p>
+            <a:r>
+              <a:rPr sz="1500"/>
+              <a:t>授课 PPT：SL_PPT.pptx（含四模块、匹配测验）；教材：SL_Manual.pdf（情境领导原著节选 + 案例）。</a:t>
+            </a:r>
+          </a:p>
+        </p:txBody>
+      </p:sp>
+    </p:spTree>
+  </p:cSld>
+  <p:clrMapOvr>
+    <a:masterClrMapping/>
+  </p:clrMapOvr>
+</p:sld>
+</file>
+
+<file path=ppt/slides/slide24.xml><?xml version="1.0" encoding="utf-8"?>
+<p:sld xmlns:a="http://schemas.openxmlformats.org/drawingml/2006/main" xmlns:p="http://schemas.openxmlformats.org/presentationml/2006/main" xmlns:r="http://schemas.openxmlformats.org/officeDocument/2006/relationships">
+  <p:cSld>
+    <p:spTree>
+      <p:nvGrpSpPr>
+        <p:cNvPr id="1" name=""/>
+        <p:cNvGrpSpPr/>
+        <p:nvPr/>
+      </p:nvGrpSpPr>
+      <p:grpSpPr/>
+      <p:sp>
+        <p:nvSpPr>
+          <p:cNvPr id="2" name="TextBox 1"/>
+          <p:cNvSpPr txBox="1"/>
+          <p:nvPr/>
+        </p:nvSpPr>
+        <p:spPr>
+          <a:xfrm>
+            <a:off x="548640" y="457200"/>
+            <a:ext cx="11064240" cy="822960"/>
+          </a:xfrm>
+          <a:prstGeom prst="rect">
+            <a:avLst/>
+          </a:prstGeom>
+          <a:noFill/>
+        </p:spPr>
+        <p:txBody>
+          <a:bodyPr wrap="square">
+            <a:spAutoFit/>
+          </a:bodyPr>
+          <a:lstStyle/>
+          <a:p>
+            <a:r>
+              <a:rPr sz="2000" b="1">
+                <a:solidFill>
+                  <a:srgbClr val="0E6B50"/>
+                </a:solidFill>
+              </a:rPr>
+              <a:t>11 · 分层与前置判定</a:t>
+            </a:r>
+          </a:p>
+        </p:txBody>
+      </p:sp>
+      <p:sp>
+        <p:nvSpPr>
+          <p:cNvPr id="3" name="TextBox 2"/>
+          <p:cNvSpPr txBox="1"/>
+          <p:nvPr/>
+        </p:nvSpPr>
+        <p:spPr>
+          <a:xfrm>
+            <a:off x="548640" y="1463040"/>
+            <a:ext cx="11064240" cy="4572000"/>
+          </a:xfrm>
+          <a:prstGeom prst="rect">
+            <a:avLst/>
+          </a:prstGeom>
+          <a:noFill/>
+        </p:spPr>
+        <p:txBody>
+          <a:bodyPr wrap="square">
+            <a:spAutoFit/>
+          </a:bodyPr>
+          <a:lstStyle/>
+          <a:p>
+            <a:r>
+              <a:rPr sz="1500"/>
+              <a:t>Tier = L2 标准单元（7h：AVG 3.5h + 非 AVG 3.5h）；Track = C1 通用改编（情境领导已有完整课件）。非 AVG 50% 分配：导入 0.9h / 复盘 1.05h / 应用 0.9h / IDP 0.7h。</a:t>
+            </a:r>
+          </a:p>
+        </p:txBody>
+      </p:sp>
+    </p:spTree>
+  </p:cSld>
+  <p:clrMapOvr>
+    <a:masterClrMapping/>
+  </p:clrMapOvr>
+</p:sld>
+</file>
+
+<file path=ppt/slides/slide25.xml><?xml version="1.0" encoding="utf-8"?>
+<p:sld xmlns:a="http://schemas.openxmlformats.org/drawingml/2006/main" xmlns:p="http://schemas.openxmlformats.org/presentationml/2006/main" xmlns:r="http://schemas.openxmlformats.org/officeDocument/2006/relationships">
+  <p:cSld>
+    <p:spTree>
+      <p:nvGrpSpPr>
+        <p:cNvPr id="1" name=""/>
+        <p:cNvGrpSpPr/>
+        <p:nvPr/>
+      </p:nvGrpSpPr>
+      <p:grpSpPr/>
+      <p:sp>
+        <p:nvSpPr>
+          <p:cNvPr id="2" name="TextBox 1"/>
+          <p:cNvSpPr txBox="1"/>
+          <p:nvPr/>
+        </p:nvSpPr>
+        <p:spPr>
+          <a:xfrm>
+            <a:off x="548640" y="457200"/>
             <a:ext cx="11064240" cy="731520"/>
           </a:xfrm>
           <a:prstGeom prst="rect">
@@ -4438,7 +4632,7 @@
           <a:p>
             <a:r>
               <a:rPr sz="1600"/>
-              <a:t>课程 → 能力(Capability) → 行为(Behavior) → 挑战(Challenge) → 探索(Exploration) → 抉择(Decision) → 后果(Consequence) → 成长(Growth) → 结局(Ending) → 复盘(Reflection) → 【应用迁移桥 Application · 强制】</a:t>
+              <a:t>【第 0 步 课程准入与分层判定 Intake &amp; Tiering】→ 课程 → 能力(Capability) → 行为(Behavior) → 挑战(Challenge) → 探索(Exploration) → 抉择(Decision) → 后果(Consequence) → 成长(Growth) → 结局(Ending) → 复盘(Reflection) → 【应用迁移桥 Application · 强制】</a:t>
             </a:r>
           </a:p>
         </p:txBody>

</xml_diff>